<commit_message>
Update Option A pricing and production proof
</commit_message>
<xml_diff>
--- a/OPTION_A_CLOSE_PACKAGE/export/allseason-owner-pitch-v3.pptx
+++ b/OPTION_A_CLOSE_PACKAGE/export/allseason-owner-pitch-v3.pptx
@@ -16683,7 +16683,7 @@
                 <a:ea typeface="Aptos Display"/>
                 <a:cs typeface="Aptos Display"/>
               </a:rPr>
-              <a:t>$5,000</a:t>
+              <a:t>$6,000</a:t>
             </a:r>
           </a:p>
         </p:txBody>
@@ -16748,7 +16748,7 @@
                 <a:ea typeface="Aptos"/>
                 <a:cs typeface="Aptos"/>
               </a:rPr>
-              <a:t>+ $3,000/mo</a:t>
+              <a:t>+ $12,000/mo</a:t>
             </a:r>
           </a:p>
         </p:txBody>
@@ -16848,7 +16848,7 @@
                 <a:ea typeface="Aptos"/>
                 <a:cs typeface="Aptos"/>
               </a:rPr>
-              <a:t>Recommended. Website, quote engine, intake, routing, reporting, monthly campaign/CRO/sequence operation.</a:t>
+              <a:t>Recommended. Website, quote engine, intake, campaign routes, RevOps map, scripts, assets, scorecard, and monthly operation.</a:t>
             </a:r>
           </a:p>
         </p:txBody>
@@ -17076,7 +17076,7 @@
                 <a:ea typeface="Aptos Display"/>
                 <a:cs typeface="Aptos Display"/>
               </a:rPr>
-              <a:t>$5,000</a:t>
+              <a:t>$6,000</a:t>
             </a:r>
           </a:p>
         </p:txBody>
@@ -17469,7 +17469,7 @@
                 <a:ea typeface="Aptos Display"/>
                 <a:cs typeface="Aptos Display"/>
               </a:rPr>
-              <a:t>$4,000/mo</a:t>
+              <a:t>$12,000/mo</a:t>
             </a:r>
           </a:p>
         </p:txBody>
@@ -18487,7 +18487,7 @@
                 <a:ea typeface="Aptos Display"/>
                 <a:cs typeface="Aptos Display"/>
               </a:rPr>
-              <a:t>One saved roof job</a:t>
+              <a:t>Operating leverage</a:t>
             </a:r>
           </a:p>
         </p:txBody>
@@ -18552,7 +18552,7 @@
                 <a:ea typeface="Aptos"/>
                 <a:cs typeface="Aptos"/>
               </a:rPr>
-              <a:t>A single closed roofing job that would have been lost to poor first-touch discipline can cover a large share of the monthly retainer.</a:t>
+              <a:t>A few saved, recovered, or better-routed jobs can cover the monthly operating seat while building an owned asset.</a:t>
             </a:r>
           </a:p>
         </p:txBody>
@@ -19896,7 +19896,7 @@
                 <a:ea typeface="Aptos Display"/>
                 <a:cs typeface="Aptos Display"/>
               </a:rPr>
-              <a:t>$5,000 buildout + $3,000/month</a:t>
+              <a:t>$6,000 buildout + $12,000/month</a:t>
             </a:r>
           </a:p>
         </p:txBody>
@@ -19961,7 +19961,7 @@
                 <a:ea typeface="Aptos"/>
                 <a:cs typeface="Aptos"/>
               </a:rPr>
-              <a:t>Reason: the website, quote engine, lead routing, scripts, and reporting only create full value when they are operated together.</a:t>
+              <a:t>Reason: the updated SOW, campaign assets, quote engine, routing, scripts, reporting, and 90-day operation work as one system.</a:t>
             </a:r>
           </a:p>
         </p:txBody>
@@ -23349,7 +23349,7 @@
                 <a:ea typeface="Aptos Display"/>
                 <a:cs typeface="Aptos Display"/>
               </a:rPr>
-              <a:t>Start Option A</a:t>
+              <a:t>Start Option A under updated SOW</a:t>
             </a:r>
           </a:p>
         </p:txBody>

</xml_diff>